<commit_message>
use accurate models and rebuild the slides for the tested process
- Ollama default is gemma3:4b from Sherlock's model library on Oak: the only
  candidate that fit a GPU slice and answered all three test questions
  correctly (llama3.2:3b and phi4-mini each got one wrong)
- the transformers server uses Qwen/Qwen2.5-1.5B-Instruct from the shared
  cache, loaded in half precision, with each prompt sent as a chat message;
  it returns only the reply, so the clients no longer trim the prompt
- Tier 2 README: how to list Sherlock's Ollama models, and a "compare a
  smaller model" exercise using the wrong answers seen in testing
- slides rebuilt from fill.py on the SRC template to match the READMEs:
  sh_dev sessions, address file, token, one-line tunnel, Claude Code module
</commit_message>
<xml_diff>
--- a/HPC-Server-Workshop.pptx
+++ b/HPC-Server-Workshop.pptx
@@ -5458,7 +5458,7 @@
             </a:pPr>
             <a:r>
               <a:rPr lang="en-US" sz="1400"/>
-              <a:t>Five tiers of one SLURM pattern — from a REST API to a browser GUI</a:t>
+              <a:t>Start one in a session, find it, keep it private, and reach it</a:t>
             </a:r>
           </a:p>
         </p:txBody>
@@ -5522,7 +5522,7 @@
             </a:pPr>
             <a:r>
               <a:rPr lang="en-US" sz="2800"/>
-              <a:t>Tier 3 — MCP: tools here, model there</a:t>
+              <a:t>Tier 3: tools for Claude</a:t>
             </a:r>
           </a:p>
         </p:txBody>
@@ -5561,7 +5561,7 @@
             </a:pPr>
             <a:r>
               <a:rPr lang="en-US" sz="1400" b="1"/>
-              <a:t>You expose tools. Claude decides which to call.</a:t>
+              <a:t>MCP lets you give Claude tools. Claude decides which to call.</a:t>
             </a:r>
           </a:p>
           <a:p>
@@ -5576,7 +5576,7 @@
             </a:pPr>
             <a:r>
               <a:rPr lang="en-US" sz="1400"/>
-              <a:t>Ask "how do I stop hitting my quota?" and it picks search_docs, then read_doc, and answers from what it finds. You never name an endpoint.</a:t>
+              <a:t>The server offers three: list, search and read a folder of documents. No GPU needed.</a:t>
             </a:r>
           </a:p>
           <a:p>
@@ -5591,7 +5591,18 @@
             </a:pPr>
             <a:r>
               <a:rPr lang="en-US" sz="1400"/>
-              <a:t>No GPU, and no model on the cluster — this process reads files and matches strings. The tools and the model are separate services; that is the point of MCP.</a:t>
+              <a:t>Claude Code runs on Sherlock too: </a:t>
+            </a:r>
+            <a:r>
+              <a:rPr lang="en-US" sz="1400">
+                <a:latin typeface="Courier New"/>
+                <a:cs typeface="Courier New"/>
+              </a:rPr>
+              <a:t>ml claude-code</a:t>
+            </a:r>
+            <a:r>
+              <a:rPr lang="en-US" sz="1400"/>
+              <a:t>, signed in with your Stanford account.</a:t>
             </a:r>
           </a:p>
           <a:p>
@@ -5606,7 +5617,7 @@
             </a:pPr>
             <a:r>
               <a:rPr lang="en-US" sz="1400"/>
-              <a:t>Streamable HTTP is ordinary HTTP, so it forwards through the very same tunnel as tier 4.</a:t>
+              <a:t>On Sherlock, Claude already reads Sherlock's own guidance, so it uses your tools when the question needs them. Questions and tool results go to Anthropic.</a:t>
             </a:r>
           </a:p>
         </p:txBody>
@@ -5670,7 +5681,7 @@
             </a:pPr>
             <a:r>
               <a:rPr lang="en-US" sz="2800"/>
-              <a:t>Where to start</a:t>
+              <a:t>Where to go next</a:t>
             </a:r>
           </a:p>
         </p:txBody>
@@ -5709,11 +5720,11 @@
             </a:pPr>
             <a:r>
               <a:rPr lang="en-US" sz="1400" b="1"/>
-              <a:t>Never run a server in a batch job?  </a:t>
+              <a:t>No tunnel at all?  </a:t>
             </a:r>
             <a:r>
               <a:rPr lang="en-US" sz="1400"/>
-              <a:t>Tier 1. The SLURM patterns there are identical in all five tiers.</a:t>
+              <a:t>Tier 5: an OnDemand session is already inside Sherlock.</a:t>
             </a:r>
           </a:p>
           <a:p>
@@ -5728,11 +5739,11 @@
             </a:pPr>
             <a:r>
               <a:rPr lang="en-US" sz="1400" b="1"/>
-              <a:t>Already have results you want to see?  </a:t>
+              <a:t>Keep the token.  </a:t>
             </a:r>
             <a:r>
               <a:rPr lang="en-US" sz="1400"/>
-              <a:t>Tier 5 — it needs no code at all.</a:t>
+              <a:t>Don't put research data behind a server anyone on Sherlock can query.</a:t>
             </a:r>
           </a:p>
           <a:p>
@@ -5747,11 +5758,11 @@
             </a:pPr>
             <a:r>
               <a:rPr lang="en-US" sz="1400" b="1"/>
-              <a:t>Want a page of your own?  </a:t>
+              <a:t>Not on the public internet.  </a:t>
             </a:r>
             <a:r>
               <a:rPr lang="en-US" sz="1400"/>
-              <a:t>Tier 4, then tier 3 once you'd rather ask questions than click.</a:t>
+              <a:t>The way in from outside is SSH with your SUNet ID and Duo.</a:t>
             </a:r>
           </a:p>
           <a:p>
@@ -5765,8 +5776,12 @@
               <a:buNone/>
             </a:pPr>
             <a:r>
+              <a:rPr lang="en-US" sz="1400" b="1"/>
+              <a:t>Something shared and long-running?  </a:t>
+            </a:r>
+            <a:r>
               <a:rPr lang="en-US" sz="1400"/>
-              <a:t>One warning: none of these servers authenticate anyone. The SSH tunnel is doing that job — keep them on loopback and off public ports.</a:t>
+              <a:t>That needs a proper service: talk to SRCC.</a:t>
             </a:r>
           </a:p>
         </p:txBody>
@@ -5830,7 +5845,7 @@
             </a:pPr>
             <a:r>
               <a:rPr lang="en-US" sz="1800"/>
-              <a:t>Keeping it all on Sherlock</a:t>
+              <a:t>A web page for your job</a:t>
             </a:r>
           </a:p>
         </p:txBody>
@@ -5868,8 +5883,8 @@
               <a:buNone/>
             </a:pPr>
             <a:r>
-              <a:rPr lang="en-US" sz="1100"/>
-              <a:t>Tier 3's default sends your prompts and the retrieved text to Anthropic.</a:t>
+              <a:rPr lang="en-US" sz="1100" b="1"/>
+              <a:t>upload an input  →  run the job  →  download the results</a:t>
             </a:r>
           </a:p>
           <a:p>
@@ -5884,18 +5899,7 @@
             </a:pPr>
             <a:r>
               <a:rPr lang="en-US" sz="1100"/>
-              <a:t>To keep it inside Stanford, run the model here too: </a:t>
-            </a:r>
-            <a:r>
-              <a:rPr lang="en-US" sz="1100">
-                <a:latin typeface="Courier New"/>
-                <a:cs typeface="Courier New"/>
-              </a:rPr>
-              <a:t>ml ollama</a:t>
-            </a:r>
-            <a:r>
-              <a:rPr lang="en-US" sz="1100"/>
-              <a:t> on a GPU node — the same service pattern as tier 2, endpoint in ~/.ollama_server.</a:t>
+              <a:t>One server sends both the page and the data behind it, so there's nothing extra to set up.</a:t>
             </a:r>
           </a:p>
           <a:p>
@@ -5910,7 +5914,7 @@
             </a:pPr>
             <a:r>
               <a:rPr lang="en-US" sz="1100"/>
-              <a:t>Then either point a CLI agent at it (OpenCode, Crush and pi all take an OpenAI-compatible base_url), or forward two ports and drive it from a local editor.</a:t>
+              <a:t>Paste your token into the page once; the browser keeps it as a cookie, so plain download links work.</a:t>
             </a:r>
           </a:p>
           <a:p>
@@ -5924,12 +5928,8 @@
               <a:buNone/>
             </a:pPr>
             <a:r>
-              <a:rPr lang="en-US" sz="1100" b="1"/>
-              <a:t>Caveat: </a:t>
-            </a:r>
-            <a:r>
               <a:rPr lang="en-US" sz="1100"/>
-              <a:t>small local models are markedly worse at multi-step tool calling, and Ollama caps context at 4k under 24 GB of GPU memory — raise num_ctx first or agents simply fail.</a:t>
+              <a:t>The job only reads inputs/ and writes results/. Your own script can take its place.</a:t>
             </a:r>
           </a:p>
         </p:txBody>
@@ -5968,7 +5968,7 @@
             </a:pPr>
             <a:r>
               <a:rPr lang="en-US" sz="2400"/>
-              <a:t>Aside</a:t>
+              <a:t>Tier 4</a:t>
             </a:r>
           </a:p>
         </p:txBody>
@@ -6032,7 +6032,7 @@
             </a:pPr>
             <a:r>
               <a:rPr lang="en-US" sz="1800"/>
-              <a:t>When you want HuggingFace instead</a:t>
+              <a:t>Running it for real</a:t>
             </a:r>
           </a:p>
         </p:txBody>
@@ -6071,78 +6071,18 @@
             </a:pPr>
             <a:r>
               <a:rPr lang="en-US" sz="1000" b="1"/>
-              <a:t>The headline: pre-tuned, domain- and task-specific models.</a:t>
-            </a:r>
-          </a:p>
-          <a:p>
-            <a:pPr indent="0" lvl="0" marL="0" rtl="0" algn="l">
-              <a:spcBef>
-                <a:spcPts val="0"/>
-              </a:spcBef>
-              <a:spcAft>
-                <a:spcPts val="600"/>
-              </a:spcAft>
-              <a:buNone/>
-            </a:pPr>
-            <a:r>
-              <a:rPr lang="en-US" sz="1000"/>
-              <a:t>The Hub carries models already tuned for a field or a task — scientific text, biomedical literature, protein sequences — that Ollama's library doesn't have. A model that knows your domain usually beats a bigger general one, on less GPU.</a:t>
-            </a:r>
-          </a:p>
-          <a:p>
-            <a:pPr indent="0" lvl="0" marL="0" rtl="0" algn="l">
-              <a:spcBef>
-                <a:spcPts val="0"/>
-              </a:spcBef>
-              <a:spcAft>
-                <a:spcPts val="600"/>
-              </a:spcAft>
-              <a:buNone/>
-            </a:pPr>
-            <a:r>
-              <a:rPr lang="en-US" sz="1000"/>
-              <a:t>Also for gated models, quantization you control, and reproducible batch inference.</a:t>
-            </a:r>
-          </a:p>
-          <a:p>
-            <a:pPr indent="0" lvl="0" marL="0" rtl="0" algn="l">
-              <a:spcBef>
-                <a:spcPts val="0"/>
-              </a:spcBef>
-              <a:spcAft>
-                <a:spcPts val="600"/>
-              </a:spcAft>
-              <a:buNone/>
-            </a:pPr>
-            <a:r>
-              <a:rPr lang="en-US" sz="1000" b="1"/>
-              <a:t>What changes: </a:t>
-            </a:r>
-            <a:r>
-              <a:rPr lang="en-US" sz="1000"/>
-              <a:t>you write the server; </a:t>
+              <a:t>Longer than a session: </a:t>
             </a:r>
             <a:r>
               <a:rPr lang="en-US" sz="1000">
                 <a:latin typeface="Courier New"/>
                 <a:cs typeface="Courier New"/>
               </a:rPr>
-              <a:t>module load pytorch</a:t>
+              <a:t>mkdir -p logs; sbatch submit_server.sh</a:t>
             </a:r>
             <a:r>
               <a:rPr lang="en-US" sz="1000"/>
-              <a:t> rather than pip-installing torch; set </a:t>
-            </a:r>
-            <a:r>
-              <a:rPr lang="en-US" sz="1000">
-                <a:latin typeface="Courier New"/>
-                <a:cs typeface="Courier New"/>
-              </a:rPr>
-              <a:t>HF_HOME=$SCRATCH/hf_cache</a:t>
-            </a:r>
-            <a:r>
-              <a:rPr lang="en-US" sz="1000"/>
-              <a:t> or you re-download weights every job; ask for a full GPU, not a MIG slice. And if the model is an encoder, change the pipeline task — text-generation is the wrong one.</a:t>
+              <a:t>. Batch jobs go to normal or gpu, not dev, and may wait in the queue.</a:t>
             </a:r>
           </a:p>
           <a:p>
@@ -6157,7 +6097,30 @@
             </a:pPr>
             <a:r>
               <a:rPr lang="en-US" sz="1000" b="1"/>
-              <a:t>Tier 2 in the repo ships both paths, scripts included.</a:t>
+              <a:t>Your own packages: </a:t>
+            </a:r>
+            <a:r>
+              <a:rPr lang="en-US" sz="1000"/>
+              <a:t>uv venv and uv pip install --no-build in $GROUP_HOME. Plain python on Sherlock is Python 2; use python3.</a:t>
+            </a:r>
+          </a:p>
+          <a:p>
+            <a:pPr indent="0" lvl="0" marL="0" rtl="0" algn="l">
+              <a:spcBef>
+                <a:spcPts val="0"/>
+              </a:spcBef>
+              <a:spcAft>
+                <a:spcPts val="600"/>
+              </a:spcAft>
+              <a:buNone/>
+            </a:pPr>
+            <a:r>
+              <a:rPr lang="en-US" sz="1000" b="1"/>
+              <a:t>Your own data: </a:t>
+            </a:r>
+            <a:r>
+              <a:rPr lang="en-US" sz="1000"/>
+              <a:t>swap the table, the model, the documents or the job. The session, address file, token and tunnel stay the same.</a:t>
             </a:r>
           </a:p>
         </p:txBody>
@@ -6196,7 +6159,7 @@
             </a:pPr>
             <a:r>
               <a:rPr lang="en-US" sz="2400"/>
-              <a:t>Tip</a:t>
+              <a:t>After today</a:t>
             </a:r>
           </a:p>
         </p:txBody>
@@ -6260,7 +6223,7 @@
             </a:pPr>
             <a:r>
               <a:rPr lang="en-US" sz="2800"/>
-              <a:t>Two problems, every single time</a:t>
+              <a:t>Three questions, every time</a:t>
             </a:r>
           </a:p>
         </p:txBody>
@@ -6303,7 +6266,7 @@
             </a:r>
             <a:r>
               <a:rPr lang="en-US" sz="1500"/>
-              <a:t>SLURM picks the node, so you cannot hardcode a hostname. The server writes its own address to a file in $SCRATCH; clients read that file.</a:t>
+              <a:t>You don't choose the node, so the server writes its machine and port to a file in $SCRATCH.</a:t>
             </a:r>
           </a:p>
           <a:p>
@@ -6318,11 +6281,11 @@
             </a:pPr>
             <a:r>
               <a:rPr lang="en-US" sz="1500" b="1"/>
-              <a:t>How do I reach it?  </a:t>
+              <a:t>Who can use it?  </a:t>
             </a:r>
             <a:r>
               <a:rPr lang="en-US" sz="1500"/>
-              <a:t>A compute node is not reachable from your laptop. You either forward a port to it, or use a browser that is already inside the cluster.</a:t>
+              <a:t>Any machine on Sherlock can reach it, so every request carries your token.</a:t>
             </a:r>
           </a:p>
           <a:p>
@@ -6337,7 +6300,26 @@
             </a:pPr>
             <a:r>
               <a:rPr lang="en-US" sz="1500" b="1"/>
-              <a:t>Everything here is those two problems, solved the same way five times.</a:t>
+              <a:t>How do I reach it?  </a:t>
+            </a:r>
+            <a:r>
+              <a:rPr lang="en-US" sz="1500"/>
+              <a:t>From Sherlock, ssh to its machine. From your laptop, one SSH tunnel.</a:t>
+            </a:r>
+          </a:p>
+          <a:p>
+            <a:pPr indent="0" lvl="0" marL="0" rtl="0" algn="l">
+              <a:spcBef>
+                <a:spcPts val="0"/>
+              </a:spcBef>
+              <a:spcAft>
+                <a:spcPts val="600"/>
+              </a:spcAft>
+              <a:buNone/>
+            </a:pPr>
+            <a:r>
+              <a:rPr lang="en-US" sz="1500" b="1"/>
+              <a:t>Every tier answers these three the same way.</a:t>
             </a:r>
           </a:p>
         </p:txBody>
@@ -6443,7 +6425,7 @@
                 <a:latin typeface="Courier New"/>
                 <a:cs typeface="Courier New"/>
               </a:rPr>
-              <a:t>$ cat $SCRATCH/hpc_workshop_gui.txt</a:t>
+              <a:t>$ cat $SCRATCH/hpc_workshop_server.txt</a:t>
             </a:r>
           </a:p>
           <a:p>
@@ -6461,7 +6443,7 @@
                 <a:latin typeface="Courier New"/>
                 <a:cs typeface="Courier New"/>
               </a:rPr>
-              <a:t>sh03-01n52:41235</a:t>
+              <a:t>sh04-18n32.int:44636</a:t>
             </a:r>
           </a:p>
           <a:p>
@@ -6476,7 +6458,7 @@
             </a:pPr>
             <a:r>
               <a:rPr lang="en-US" sz="1200"/>
-              <a:t>An ephemeral port, so two people on one node don't collide.</a:t>
+              <a:t>It picks a free port, so people on the same machine don't clash.</a:t>
             </a:r>
           </a:p>
           <a:p>
@@ -6491,7 +6473,18 @@
             </a:pPr>
             <a:r>
               <a:rPr lang="en-US" sz="1200"/>
-              <a:t>&lt;node&gt;:&lt;port&gt; is the format the Sherlock Ollama docs use — both halves pull straight back out with shell expansion.</a:t>
+              <a:t>To use it from another terminal, </a:t>
+            </a:r>
+            <a:r>
+              <a:rPr lang="en-US" sz="1200">
+                <a:latin typeface="Courier New"/>
+                <a:cs typeface="Courier New"/>
+              </a:rPr>
+              <a:t>ssh sh04-18n32</a:t>
+            </a:r>
+            <a:r>
+              <a:rPr lang="en-US" sz="1200"/>
+              <a:t> first. You land inside your session's job.</a:t>
             </a:r>
           </a:p>
         </p:txBody>
@@ -6530,7 +6523,7 @@
             </a:pPr>
             <a:r>
               <a:rPr lang="en-US" sz="2400"/>
-              <a:t>1. Discovery</a:t>
+              <a:t>1. Where is it?</a:t>
             </a:r>
           </a:p>
         </p:txBody>
@@ -6594,7 +6587,7 @@
             </a:pPr>
             <a:r>
               <a:rPr lang="en-US" sz="2800"/>
-              <a:t>The five tiers</a:t>
+              <a:t>The day</a:t>
             </a:r>
           </a:p>
         </p:txBody>
@@ -6633,11 +6626,11 @@
             </a:pPr>
             <a:r>
               <a:rPr lang="en-US" sz="1400" b="1"/>
-              <a:t>01  Data server  </a:t>
+              <a:t>Morning  </a:t>
             </a:r>
             <a:r>
               <a:rPr lang="en-US" sz="1400"/>
-              <a:t>— serve a CSV over REST.  Any compute node.</a:t>
+              <a:t>Tier 1: a data server.  Tier 2: a language model on a GPU.</a:t>
             </a:r>
           </a:p>
           <a:p>
@@ -6652,11 +6645,11 @@
             </a:pPr>
             <a:r>
               <a:rPr lang="en-US" sz="1400" b="1"/>
-              <a:t>02  Model server  </a:t>
+              <a:t>Afternoon  </a:t>
             </a:r>
             <a:r>
               <a:rPr lang="en-US" sz="1400"/>
-              <a:t>— ml ollama on an instant MIG slice.</a:t>
+              <a:t>Tier 3: tools for Claude (MCP).  Tier 4: a web page for your job.</a:t>
             </a:r>
           </a:p>
           <a:p>
@@ -6671,11 +6664,11 @@
             </a:pPr>
             <a:r>
               <a:rPr lang="en-US" sz="1400" b="1"/>
-              <a:t>03  MCP server  </a:t>
+              <a:t>On your own  </a:t>
             </a:r>
             <a:r>
               <a:rPr lang="en-US" sz="1400"/>
-              <a:t>— give Claude structured tool access.  No GPU.</a:t>
+              <a:t>Tier 5: Open OnDemand, with no tunnel.</a:t>
             </a:r>
           </a:p>
           <a:p>
@@ -6689,46 +6682,19 @@
               <a:buNone/>
             </a:pPr>
             <a:r>
-              <a:rPr lang="en-US" sz="1400" b="1"/>
-              <a:t>04  Web GUI  </a:t>
-            </a:r>
-            <a:r>
               <a:rPr lang="en-US" sz="1400"/>
-              <a:t>— drive a job from your laptop's browser.  Any node.</a:t>
-            </a:r>
-          </a:p>
-          <a:p>
-            <a:pPr indent="0" lvl="0" marL="0" rtl="0" algn="l">
-              <a:spcBef>
-                <a:spcPts val="0"/>
-              </a:spcBef>
-              <a:spcAft>
-                <a:spcPts val="600"/>
-              </a:spcAft>
-              <a:buNone/>
-            </a:pPr>
-            <a:r>
-              <a:rPr lang="en-US" sz="1400" b="1"/>
-              <a:t>05  OnDemand  </a:t>
+              <a:t>Everything runs in </a:t>
+            </a:r>
+            <a:r>
+              <a:rPr lang="en-US" sz="1400">
+                <a:latin typeface="Courier New"/>
+                <a:cs typeface="Courier New"/>
+              </a:rPr>
+              <a:t>sh_dev</a:t>
             </a:r>
             <a:r>
               <a:rPr lang="en-US" sz="1400"/>
-              <a:t>— the same, in-browser, with no tunnel at all.</a:t>
-            </a:r>
-          </a:p>
-          <a:p>
-            <a:pPr indent="0" lvl="0" marL="0" rtl="0" algn="l">
-              <a:spcBef>
-                <a:spcPts val="0"/>
-              </a:spcBef>
-              <a:spcAft>
-                <a:spcPts val="600"/>
-              </a:spcAft>
-              <a:buNone/>
-            </a:pPr>
-            <a:r>
-              <a:rPr lang="en-US" sz="1400"/>
-              <a:t>Each is self-contained. The discovery and tunnel patterns are identical in all five.</a:t>
+              <a:t> sessions, with Sherlock's modules and a shared set of Python packages. Nothing to install.</a:t>
             </a:r>
           </a:p>
         </p:txBody>
@@ -6792,7 +6758,7 @@
             </a:pPr>
             <a:r>
               <a:rPr lang="en-US" sz="2800"/>
-              <a:t>2. The tunnel — where everyone trips</a:t>
+              <a:t>2. Who can use it? The token</a:t>
             </a:r>
           </a:p>
         </p:txBody>
@@ -6830,8 +6796,11 @@
               <a:buNone/>
             </a:pPr>
             <a:r>
-              <a:rPr lang="en-US" sz="1400" b="1"/>
-              <a:t>The bind address and the tunnel target must agree.</a:t>
+              <a:rPr lang="en-US" sz="1300">
+                <a:latin typeface="Courier New"/>
+                <a:cs typeface="Courier New"/>
+              </a:rPr>
+              <a:t>python3 -c "import secrets; print(secrets.token_urlsafe(32))" &gt; ~/.hpc_workshop/token</a:t>
             </a:r>
           </a:p>
           <a:p>
@@ -6845,15 +6814,11 @@
               <a:buNone/>
             </a:pPr>
             <a:r>
-              <a:rPr lang="en-US" sz="1400"/>
-              <a:t>Server on 127.0.0.1  →  </a:t>
-            </a:r>
-            <a:r>
-              <a:rPr lang="en-US" sz="1400">
+              <a:rPr lang="en-US" sz="1300">
                 <a:latin typeface="Courier New"/>
                 <a:cs typeface="Courier New"/>
               </a:rPr>
-              <a:t>ssh -NfL 8080:localhost:PORT NODE</a:t>
+              <a:t>chmod 600 ~/.hpc_workshop/token</a:t>
             </a:r>
           </a:p>
           <a:p>
@@ -6867,8 +6832,8 @@
               <a:buNone/>
             </a:pPr>
             <a:r>
-              <a:rPr lang="en-US" sz="1400"/>
-              <a:t>      Encrypted end to end. Needs a running job on that node.</a:t>
+              <a:rPr lang="en-US" sz="1300"/>
+              <a:t>Every request sends it; without it the server answers 401.</a:t>
             </a:r>
           </a:p>
           <a:p>
@@ -6882,15 +6847,12 @@
               <a:buNone/>
             </a:pPr>
             <a:r>
-              <a:rPr lang="en-US" sz="1400"/>
-              <a:t>Server on 0.0.0.0  →  </a:t>
-            </a:r>
-            <a:r>
-              <a:rPr lang="en-US" sz="1400">
-                <a:latin typeface="Courier New"/>
-                <a:cs typeface="Courier New"/>
-              </a:rPr>
-              <a:t>ssh -NfL 8080:NODE:PORT login.sherlock</a:t>
+              <a:rPr lang="en-US" sz="1300" b="1"/>
+              <a:t>For your lab: </a:t>
+            </a:r>
+            <a:r>
+              <a:rPr lang="en-US" sz="1300"/>
+              <a:t>a group-readable token file in $GROUP_HOME.</a:t>
             </a:r>
           </a:p>
           <a:p>
@@ -6904,23 +6866,8 @@
               <a:buNone/>
             </a:pPr>
             <a:r>
-              <a:rPr lang="en-US" sz="1400"/>
-              <a:t>      Works without node access, but the last hop is cleartext internally.</a:t>
-            </a:r>
-          </a:p>
-          <a:p>
-            <a:pPr indent="0" lvl="0" marL="0" rtl="0" algn="l">
-              <a:spcBef>
-                <a:spcPts val="0"/>
-              </a:spcBef>
-              <a:spcAft>
-                <a:spcPts val="600"/>
-              </a:spcAft>
-              <a:buNone/>
-            </a:pPr>
-            <a:r>
-              <a:rPr lang="en-US" sz="1400"/>
-              <a:t>Then open http://localhost:8080 — localhost, not the node name.</a:t>
+              <a:rPr lang="en-US" sz="1300"/>
+              <a:t>Ollama has no token, so it only accepts connections from its own machine.</a:t>
             </a:r>
           </a:p>
         </p:txBody>
@@ -6984,7 +6931,7 @@
             </a:pPr>
             <a:r>
               <a:rPr lang="en-US" sz="2800"/>
-              <a:t>Tier 4 — a page you actually wrote</a:t>
+              <a:t>3. How do I reach it from my laptop?</a:t>
             </a:r>
           </a:p>
         </p:txBody>
@@ -7023,7 +6970,7 @@
             </a:pPr>
             <a:r>
               <a:rPr lang="en-US" sz="1400" b="1"/>
-              <a:t>upload an input  →  job runs on the cluster  →  download the output</a:t>
+              <a:t>One command on your laptop:</a:t>
             </a:r>
           </a:p>
           <a:p>
@@ -7037,8 +6984,11 @@
               <a:buNone/>
             </a:pPr>
             <a:r>
-              <a:rPr lang="en-US" sz="1400"/>
-              <a:t>The page and the API come from one FastAPI app. Same origin, so there is no CORS to configure, no second web server, and no build step.</a:t>
+              <a:rPr lang="en-US" sz="1400">
+                <a:latin typeface="Courier New"/>
+                <a:cs typeface="Courier New"/>
+              </a:rPr>
+              <a:t>ssh -N -L 8080:&lt;machine&gt;:&lt;port&gt; login.sherlock.stanford.edu</a:t>
             </a:r>
           </a:p>
           <a:p>
@@ -7053,7 +7003,7 @@
             </a:pPr>
             <a:r>
               <a:rPr lang="en-US" sz="1400"/>
-              <a:t>Serve them separately and you hit cross-origin errors immediately — which is when people start pasting wildcard CORS onto an unauthenticated server.</a:t>
+              <a:t>Then open http://localhost:8080. Your laptop's port 8080 now leads to the server.</a:t>
             </a:r>
           </a:p>
           <a:p>
@@ -7068,7 +7018,33 @@
             </a:pPr>
             <a:r>
               <a:rPr lang="en-US" sz="1400"/>
-              <a:t>Point RESULTS_DIR at a directory your pipeline already writes to and the page lists those files with no code changes.</a:t>
+              <a:t>SUNet password and Duo as usual. Ctrl-C closes the tunnel.</a:t>
+            </a:r>
+          </a:p>
+          <a:p>
+            <a:pPr indent="0" lvl="0" marL="0" rtl="0" algn="l">
+              <a:spcBef>
+                <a:spcPts val="0"/>
+              </a:spcBef>
+              <a:spcAft>
+                <a:spcPts val="600"/>
+              </a:spcAft>
+              <a:buNone/>
+            </a:pPr>
+            <a:r>
+              <a:rPr lang="en-US" sz="1400"/>
+              <a:t>If your SSH config shares connections (ControlMaster), a closed tunnel can keep the port. </a:t>
+            </a:r>
+            <a:r>
+              <a:rPr lang="en-US" sz="1400">
+                <a:latin typeface="Courier New"/>
+                <a:cs typeface="Courier New"/>
+              </a:rPr>
+              <a:t>ssh -O exit</a:t>
+            </a:r>
+            <a:r>
+              <a:rPr lang="en-US" sz="1400"/>
+              <a:t> frees it.</a:t>
             </a:r>
           </a:p>
         </p:txBody>
@@ -7132,7 +7108,7 @@
             </a:pPr>
             <a:r>
               <a:rPr lang="en-US" sz="2800"/>
-              <a:t>Tier 5 — OnDemand, no tunnel</a:t>
+              <a:t>Tier 2: a model on a GPU slice</a:t>
             </a:r>
           </a:p>
         </p:txBody>
@@ -7170,8 +7146,15 @@
               <a:buNone/>
             </a:pPr>
             <a:r>
-              <a:rPr lang="en-US" sz="1400" b="1"/>
-              <a:t>An OOD session already runs on a compute node. The browser is inside the cluster, so nothing needs forwarding.</a:t>
+              <a:rPr lang="en-US" sz="1400">
+                <a:latin typeface="Courier New"/>
+                <a:cs typeface="Courier New"/>
+              </a:rPr>
+              <a:t>sh_dev -g 1 -m 8000</a:t>
+            </a:r>
+            <a:r>
+              <a:rPr lang="en-US" sz="1400"/>
+              <a:t>  one slice of a GPU (6 GB), usually right away</a:t>
             </a:r>
           </a:p>
           <a:p>
@@ -7185,8 +7168,19 @@
               <a:buNone/>
             </a:pPr>
             <a:r>
+              <a:rPr lang="en-US" sz="1400" b="1"/>
+              <a:t>Ollama:  </a:t>
+            </a:r>
+            <a:r>
+              <a:rPr lang="en-US" sz="1400">
+                <a:latin typeface="Courier New"/>
+                <a:cs typeface="Courier New"/>
+              </a:rPr>
+              <a:t>ml ollama</a:t>
+            </a:r>
+            <a:r>
               <a:rPr lang="en-US" sz="1400"/>
-              <a:t>Jupyter, code-server, RStudio, TensorBoard, Interactive Desktop, and a file browser — all there, no code required.</a:t>
+              <a:t>. Models come from Sherlock's library on Oak; we use gemma3:4b.</a:t>
             </a:r>
           </a:p>
           <a:p>
@@ -7200,8 +7194,12 @@
               <a:buNone/>
             </a:pPr>
             <a:r>
+              <a:rPr lang="en-US" sz="1400" b="1"/>
+              <a:t>Your own server:  </a:t>
+            </a:r>
+            <a:r>
               <a:rPr lang="en-US" sz="1400"/>
-              <a:t>For "I just want my results on my laptop," the Files menu already does it.</a:t>
+              <a:t>Hugging Face transformers with Qwen2.5-1.5B-Instruct, behind your token.</a:t>
             </a:r>
           </a:p>
           <a:p>
@@ -7215,8 +7213,12 @@
               <a:buNone/>
             </a:pPr>
             <a:r>
+              <a:rPr lang="en-US" sz="1400" b="1"/>
+              <a:t>Test models before you trust them. </a:t>
+            </a:r>
+            <a:r>
               <a:rPr lang="en-US" sz="1400"/>
-              <a:t>To let your lab launch your own tool from the dashboard, you package it as a custom interactive app — that one needs SRCC.</a:t>
+              <a:t>Smaller ones made up what SLURM stands for, or turned 4 × 4000 MB into 32000 GB.</a:t>
             </a:r>
           </a:p>
         </p:txBody>

</xml_diff>

<commit_message>
tunnel commands use -S none so Ctrl-C always frees the laptop port; slides rebuilt
</commit_message>
<xml_diff>
--- a/HPC-Server-Workshop.pptx
+++ b/HPC-Server-Workshop.pptx
@@ -6988,7 +6988,7 @@
                 <a:latin typeface="Courier New"/>
                 <a:cs typeface="Courier New"/>
               </a:rPr>
-              <a:t>ssh -N -L 8080:&lt;machine&gt;:&lt;port&gt; login.sherlock.stanford.edu</a:t>
+              <a:t>ssh -S none -N -L 8080:&lt;machine&gt;:&lt;port&gt; login.sherlock.stanford.edu</a:t>
             </a:r>
           </a:p>
           <a:p>
@@ -7031,20 +7031,16 @@
               </a:spcAft>
               <a:buNone/>
             </a:pPr>
-            <a:r>
-              <a:rPr lang="en-US" sz="1400"/>
-              <a:t>If your SSH config shares connections (ControlMaster), a closed tunnel can keep the port. </a:t>
-            </a:r>
             <a:r>
               <a:rPr lang="en-US" sz="1400">
                 <a:latin typeface="Courier New"/>
                 <a:cs typeface="Courier New"/>
               </a:rPr>
-              <a:t>ssh -O exit</a:t>
+              <a:t>-S none</a:t>
             </a:r>
             <a:r>
               <a:rPr lang="en-US" sz="1400"/>
-              <a:t> frees it.</a:t>
+              <a:t> makes it its own connection, so Ctrl-C always frees the port.</a:t>
             </a:r>
           </a:p>
         </p:txBody>

</xml_diff>

<commit_message>
Drop the claim that SRCC runs long-term servers
</commit_message>
<xml_diff>
--- a/HPC-Server-Workshop.pptx
+++ b/HPC-Server-Workshop.pptx
@@ -5777,11 +5777,11 @@
             </a:pPr>
             <a:r>
               <a:rPr lang="en-US" sz="1400" b="1"/>
-              <a:t>Something shared and long-running?  </a:t>
+              <a:t>Servers for while you work.  </a:t>
             </a:r>
             <a:r>
               <a:rPr lang="en-US" sz="1400"/>
-              <a:t>That needs a proper service: talk to SRCC.</a:t>
+              <a:t>Start one in a session or job, use it, and it stops when that ends.</a:t>
             </a:r>
           </a:p>
         </p:txBody>

</xml_diff>